<commit_message>
Design Phase: Design Phase Presentation Ready
</commit_message>
<xml_diff>
--- a/DesignPhase_Presentation.pptx
+++ b/DesignPhase_Presentation.pptx
@@ -4221,7 +4221,7 @@
         <p:spPr>
           <a:xfrm>
             <a:off x="548640" y="2615184"/>
-            <a:ext cx="11064240" cy="640080"/>
+            <a:ext cx="11064240" cy="553998"/>
           </a:xfrm>
           <a:prstGeom prst="rect">
             <a:avLst/>
@@ -4236,13 +4236,67 @@
           <a:p>
             <a:pPr algn="l"/>
             <a:r>
-              <a:rPr sz="1500" b="0" i="0">
-                <a:solidFill>
-                  <a:srgbClr val="CCCCDD"/>
-                </a:solidFill>
-                <a:latin typeface="Segoe UI"/>
-              </a:rPr>
-              <a:t>Action 1 — Log an expense and check if it exceeds a category budget.  Action 2 — View the next upcoming bill and mark it as paid.  Action 3 — Query spending history by date range.</a:t>
+              <a:rPr sz="1500" b="0" i="0" dirty="0">
+                <a:solidFill>
+                  <a:srgbClr val="CCCCDD"/>
+                </a:solidFill>
+                <a:latin typeface="Segoe UI"/>
+              </a:rPr>
+              <a:t>Action 1 — Log an expense and check if it exceeds a category budget.  Action 2 — View the next upcoming bill and mark </a:t>
+            </a:r>
+            <a:r>
+              <a:rPr lang="en-US" sz="1500" b="0" i="0" dirty="0">
+                <a:solidFill>
+                  <a:srgbClr val="CCCCDD"/>
+                </a:solidFill>
+                <a:latin typeface="Segoe UI"/>
+              </a:rPr>
+              <a:t>as paid/not paid</a:t>
+            </a:r>
+            <a:r>
+              <a:rPr lang="en-US" sz="1500" dirty="0">
+                <a:solidFill>
+                  <a:srgbClr val="CCCCDD"/>
+                </a:solidFill>
+                <a:latin typeface="Segoe UI"/>
+              </a:rPr>
+              <a:t> </a:t>
+            </a:r>
+            <a:r>
+              <a:rPr lang="en-US" sz="1500" b="0" i="0" dirty="0">
+                <a:solidFill>
+                  <a:srgbClr val="CCCCDD"/>
+                </a:solidFill>
+                <a:latin typeface="Segoe UI"/>
+              </a:rPr>
+              <a:t>and give prioritized alerts</a:t>
+            </a:r>
+            <a:r>
+              <a:rPr sz="1500" b="0" i="0" dirty="0">
+                <a:solidFill>
+                  <a:srgbClr val="CCCCDD"/>
+                </a:solidFill>
+                <a:latin typeface="Segoe UI"/>
+              </a:rPr>
+              <a:t>.  Action 3 — Query spending history by date range</a:t>
+            </a:r>
+            <a:r>
+              <a:rPr lang="en-US" sz="1500" b="0" i="0" dirty="0">
+                <a:solidFill>
+                  <a:srgbClr val="CCCCDD"/>
+                </a:solidFill>
+                <a:latin typeface="Segoe UI"/>
+              </a:rPr>
+              <a:t> &amp; category</a:t>
+            </a:r>
+            <a:r>
+              <a:rPr sz="1500" b="0" i="0" dirty="0">
+                <a:solidFill>
+                  <a:srgbClr val="CCCCDD"/>
+                </a:solidFill>
+                <a:latin typeface="Segoe UI"/>
+              </a:rPr>
+              <a:t>.</a:t>
             </a:r>
           </a:p>
         </p:txBody>
@@ -4306,13 +4360,49 @@
           <a:p>
             <a:pPr algn="l"/>
             <a:r>
-              <a:rPr sz="1500" b="0" i="0">
-                <a:solidFill>
-                  <a:srgbClr val="CCCCDD"/>
-                </a:solidFill>
-                <a:latin typeface="Segoe UI"/>
-              </a:rPr>
-              <a:t>The system is composed of 7 components: Expense, Bill, CategoryInfo, HashMap, MinHeap, BST, and BudgetManager. All data structures are implemented from scratch. 8 header files define the full interface, reviewed and finalized before implementation.</a:t>
+              <a:rPr sz="1500" b="0" i="0" dirty="0">
+                <a:solidFill>
+                  <a:srgbClr val="CCCCDD"/>
+                </a:solidFill>
+                <a:latin typeface="Segoe UI"/>
+              </a:rPr>
+              <a:t>The system is composed of 7 components: Expense, Bill, CategoryInfo, HashMap, </a:t>
+            </a:r>
+            <a:r>
+              <a:rPr sz="1500" b="0" i="0" dirty="0" err="1">
+                <a:solidFill>
+                  <a:srgbClr val="CCCCDD"/>
+                </a:solidFill>
+                <a:latin typeface="Segoe UI"/>
+              </a:rPr>
+              <a:t>MinHeap</a:t>
+            </a:r>
+            <a:r>
+              <a:rPr sz="1500" b="0" i="0" dirty="0">
+                <a:solidFill>
+                  <a:srgbClr val="CCCCDD"/>
+                </a:solidFill>
+                <a:latin typeface="Segoe UI"/>
+              </a:rPr>
+              <a:t>, BST, and </a:t>
+            </a:r>
+            <a:r>
+              <a:rPr sz="1500" b="0" i="0" dirty="0" err="1">
+                <a:solidFill>
+                  <a:srgbClr val="CCCCDD"/>
+                </a:solidFill>
+                <a:latin typeface="Segoe UI"/>
+              </a:rPr>
+              <a:t>BudgetManager</a:t>
+            </a:r>
+            <a:r>
+              <a:rPr sz="1500" b="0" i="0" dirty="0">
+                <a:solidFill>
+                  <a:srgbClr val="CCCCDD"/>
+                </a:solidFill>
+                <a:latin typeface="Segoe UI"/>
+              </a:rPr>
+              <a:t>. All data structures are implemented from scratch. 8 header files define the full interface, reviewed and finalized before implementation.</a:t>
             </a:r>
           </a:p>
         </p:txBody>

</xml_diff>